<commit_message>
Presentationen: nivå 1/2/3 istället för betygsnivåer E/C/A
Co-Authored-By: Claude Fable 5 <noreply@anthropic.com>
</commit_message>
<xml_diff>
--- a/Driverbot250s-ROS2.pptx
+++ b/Driverbot250s-ROS2.pptx
@@ -1012,7 +1012,7 @@
           <a:lstStyle/>
           <a:p>
             <a:r>
-              <a:t>C-nivån är exakt labb 10. A-nivån: eleven väljer ett beteende, mäter täckning per tidsenhet med pennan och jämför med slumpvarianten. UNDVIK RITAT är det som direkt höjer täckningen: bilen styr bort från yta den redan täckt.</a:t>
+              <a:t>Nivå 2 är exakt labb 10. Nivå 3: eleven väljer ett beteende, mäter täckning per tidsenhet med pennan och jämför med slumpvarianten. UNDVIK RITAT är det som direkt höjer täckningen: bilen styr bort från yta den redan täckt.</a:t>
             </a:r>
           </a:p>
         </p:txBody>
@@ -1082,7 +1082,7 @@
           <a:lstStyle/>
           <a:p>
             <a:r>
-              <a:t>E-nivå = kedjan fungerar hela vägen: eleven kör bilen med tangentbordet via ROS2 och ser sensorvärdet i ROS2. Ingen autonomi krävs för godkänt. Motsvarar "med viss säkerhet" i kriterierna.</a:t>
+              <a:t>Nivå 1 = kedjan fungerar hela vägen: eleven kör bilen med tangentbordet via ROS2 och ser sensorvärdet i ROS2. Ingen autonomi krävs här.</a:t>
             </a:r>
           </a:p>
         </p:txBody>
@@ -1152,7 +1152,7 @@
           <a:lstStyle/>
           <a:p>
             <a:r>
-              <a:t>C-nivå = första autonoma beteendet (stanna själv) och sedan moppen som städar själv, med resultatet mätt och analyserat. "Med säkerhet", "genomarbetade beräkningar".</a:t>
+              <a:t>Nivå 2 = första autonoma beteendet (stanna själv) och sedan moppen som städar själv, med resultatet mätt och analyserat.</a:t>
             </a:r>
           </a:p>
         </p:txBody>
@@ -1222,7 +1222,7 @@
           <a:lstStyle/>
           <a:p>
             <a:r>
-              <a:t>A-nivå = eleven väljer och motiverar en strategi med mätdata, och kopplar till hållbarhet. "Med god säkerhet", "väl genomarbetade beräkningar", "mycket god skicklighet" i kommunikation.</a:t>
+              <a:t>Nivå 3 = eleven väljer och motiverar en strategi med mätdata, och kopplar till hållbarhet.</a:t>
             </a:r>
           </a:p>
         </p:txBody>
@@ -1712,7 +1712,7 @@
           <a:lstStyle/>
           <a:p>
             <a:r>
-              <a:t>Ultraljud räcker för C. Ljussensorn ger A-beteendet: se pennspåret (mörkt = redan städat) och styra mot oritad yta. LDR + 10 kOhm som spänningsdelare till A0. Kalibrera tröskeln med ros2 topic echo /ljus.</a:t>
+              <a:t>Ultraljud räcker för nivå 2. Ljussensorn ger nivå 3-beteendet: se pennspåret (mörkt = redan städat) och styra mot oritad yta. LDR + 10 kOhm som spänningsdelare till A0. Kalibrera tröskeln med ros2 topic echo /ljus.</a:t>
             </a:r>
           </a:p>
         </p:txBody>
@@ -1782,7 +1782,7 @@
           <a:lstStyle/>
           <a:p>
             <a:r>
-              <a:t>Kopplar direkt till centralt innehåll: mätning, testning, beräkning, rimlighetsbedömning. Rimlighetsbedömning A-nivå: om moppen täcker 60 % av 4 m² på 2 min — hur lång tid tar ett klassrum?</a:t>
+              <a:t>Kopplar direkt till centralt innehåll: mätning, testning, beräkning, rimlighetsbedömning. Rimlighetsbedömning på nivå 3: om moppen täcker 60 % av 4 m² på 2 min — hur lång tid tar ett klassrum?</a:t>
             </a:r>
           </a:p>
         </p:txBody>
@@ -6732,7 +6732,7 @@
             </a:pPr>
             <a:r>
               <a:rPr b="0" sz="1600"/>
-              <a:t>A-nivå: ljussensor på A0 → &lt;epost&gt;/ljus (0–1023)</a:t>
+              <a:t>Nivå 3: ljussensor på A0 → &lt;epost&gt;/ljus (0–1023)</a:t>
             </a:r>
           </a:p>
         </p:txBody>
@@ -7781,7 +7781,7 @@
                   <a:srgbClr val="3D3D3D"/>
                 </a:solidFill>
               </a:rPr>
-              <a:t>C-nivå: slumpstädning, som en tidig Roomba. Täcker ytan till slut — men hur lång tid tar det? Mät!</a:t>
+              <a:t>Nivå 2: slumpstädning, som en tidig Roomba. Täcker ytan till slut — men hur lång tid tar det? Mät!</a:t>
             </a:r>
           </a:p>
         </p:txBody>
@@ -7815,7 +7815,7 @@
                   <a:srgbClr val="1A3260"/>
                 </a:solidFill>
               </a:rPr>
-              <a:t>A-nivå: ett smartare beteende — med bara ultraljud + ljussensor</a:t>
+              <a:t>Nivå 3: ett smartare beteende — med bara ultraljud + ljussensor</a:t>
             </a:r>
           </a:p>
         </p:txBody>
@@ -8047,7 +8047,7 @@
           <a:lstStyle/>
           <a:p>
             <a:r>
-              <a:t>E-nivå</a:t>
+              <a:t>Nivå 1 — kedjan fungerar</a:t>
             </a:r>
           </a:p>
         </p:txBody>
@@ -8154,7 +8154,7 @@
             </a:pPr>
             <a:r>
               <a:rPr b="1" sz="1600"/>
-              <a:t>Godkänt = du styr bilen manuellt från ROS2 (teleop) — hela kedjan ROS2 → MQTT → ESP fungerar</a:t>
+              <a:t>Målet på nivå 1: du styr bilen manuellt från ROS2 (teleop) — hela kedjan ROS2 → MQTT → ESP fungerar</a:t>
             </a:r>
           </a:p>
           <a:p>
@@ -8237,7 +8237,7 @@
           <a:lstStyle/>
           <a:p>
             <a:r>
-              <a:t>C-nivå</a:t>
+              <a:t>Nivå 2 — moppen städar själv</a:t>
             </a:r>
           </a:p>
         </p:txBody>
@@ -8438,7 +8438,7 @@
           <a:lstStyle/>
           <a:p>
             <a:r>
-              <a:t>A-nivå</a:t>
+              <a:t>Nivå 3 — smartare städning</a:t>
             </a:r>
           </a:p>
         </p:txBody>
@@ -12992,7 +12992,7 @@
                             <a:srgbClr val="3D3D3D"/>
                           </a:solidFill>
                         </a:rPr>
-                        <a:t>E och C — räcker för slumpstädning</a:t>
+                        <a:t>Nivå 1 och 2 — räcker för slumpstädning</a:t>
                       </a:r>
                     </a:p>
                   </a:txBody>
@@ -13078,7 +13078,7 @@
                             <a:srgbClr val="3D3D3D"/>
                           </a:solidFill>
                         </a:rPr>
-                        <a:t>A — täck det oritade</a:t>
+                        <a:t>Nivå 3 — täck det oritade</a:t>
                       </a:r>
                     </a:p>
                   </a:txBody>
@@ -13143,7 +13143,7 @@
                   <a:srgbClr val="3D3D3D"/>
                 </a:solidFill>
               </a:rPr>
-              <a:t>Krävs: ultraljud. A-nivå: ultraljud + ljussensor. Inget annat — inga gyron, encoders eller kameror.</a:t>
+              <a:t>Krävs: ultraljud. Nivå 3: ultraljud + ljussensor. Inget annat — inga gyron, encoders eller kameror.</a:t>
             </a:r>
           </a:p>
           <a:p>
@@ -14924,7 +14924,7 @@
                   <a:srgbClr val="3D3D3D"/>
                 </a:solidFill>
               </a:rPr>
-              <a:t>Steg 1–3 är Teknik, steg 4–8 är Programmering. Steg 1–5 räcker för godkänt (manuell styrning från ROS2). Grupper om 2: en bygger medan en kodar, byt sedan.</a:t>
+              <a:t>Steg 1–3 är Teknik, steg 4–8 är Programmering. Steg 1–5 räcker för nivå 1 (manuell styrning från ROS2). Grupper om 2: en bygger medan en kodar, byt sedan.</a:t>
             </a:r>
           </a:p>
         </p:txBody>

</xml_diff>

<commit_message>
Presentationen: Raspberry Pi-referenser borttagna ur talarnoter och resurser
Co-Authored-By: Claude Fable 5 <noreply@anthropic.com>
</commit_message>
<xml_diff>
--- a/Driverbot250s-ROS2.pptx
+++ b/Driverbot250s-ROS2.pptx
@@ -1432,7 +1432,7 @@
           <a:lstStyle/>
           <a:p>
             <a:r>
-              <a:t>ROS2 kan inte köras på en ESP8266, och behöver inte det. ROS2 körs på datorn, bilen är en "drivrutin". Det är så riktiga robotar är byggda. Se ROS2/fran-turtlesim-till-riktig-bil.md för motiveringen (och varför inte Raspberry Pi).</a:t>
+              <a:t>ROS2 kan inte köras på en ESP8266, och behöver inte det. ROS2 körs på datorn, bilen är en "drivrutin". Det är så riktiga robotar är byggda. Se ROS2/fran-turtlesim-till-riktig-bil.md för motiveringen.</a:t>
             </a:r>
           </a:p>
         </p:txBody>
@@ -9572,7 +9572,7 @@
             </a:pPr>
             <a:r>
               <a:rPr sz="1600" b="0"/>
-              <a:t>ROS2/fran-turtlesim-till-riktig-bil.md — varför brygga och inte Raspberry Pi; sensorer på Pi</a:t>
+              <a:t>ROS2/fran-turtlesim-till-riktig-bil.md — bakgrund och motivering till bryggan</a:t>
             </a:r>
           </a:p>
           <a:p>

</xml_diff>

<commit_message>
Labb 8: robotmopp i simulering istället för fritt slutprojekt; nivå 1 = manuell täckning av alla rutor
- Labb 8 omgjord: täckningsmätare, manuell städning (nivå 1-repetition),
  autonom städare med bilens tillståndsmaskin (BACKA_SVANG), launch-fil
- Labb 9/10 + README: nivå 1 = teleop + beröra alla rutor, nivå 2-3 = autonomt
- Presentationen uppdaterad med samma nivådefinition och nya labb 8-referenser

Co-Authored-By: Claude Fable 5 <noreply@anthropic.com>
</commit_message>
<xml_diff>
--- a/Driverbot250s-ROS2.pptx
+++ b/Driverbot250s-ROS2.pptx
@@ -1082,7 +1082,7 @@
           <a:lstStyle/>
           <a:p>
             <a:r>
-              <a:t>Nivå 1 = kedjan fungerar hela vägen: eleven kör bilen med tangentbordet via ROS2 och ser sensorvärdet i ROS2. Ingen autonomi krävs här.</a:t>
+              <a:t>Nivå 1 = kedjan fungerar hela vägen OCH eleven täcker hela arenan (alla 64 rutor) manuellt med teleop, med tiden antecknad. Ingen autonomi krävs här — den börjar på nivå 2.</a:t>
             </a:r>
           </a:p>
         </p:txBody>
@@ -8047,7 +8047,7 @@
           <a:lstStyle/>
           <a:p>
             <a:r>
-              <a:t>Nivå 1 — kedjan fungerar</a:t>
+              <a:t>Nivå 1 — städa manuellt från ROS2</a:t>
             </a:r>
           </a:p>
         </p:txBody>
@@ -8106,7 +8106,7 @@
             </a:pPr>
             <a:r>
               <a:rPr b="0" sz="1600"/>
-              <a:t>Bygg (i grupp) en arena med kartongväggar</a:t>
+              <a:t>Bygg (i grupp) en arena med kartongväggar och rutnät 25 cm</a:t>
             </a:r>
           </a:p>
           <a:p>
@@ -8154,7 +8154,7 @@
             </a:pPr>
             <a:r>
               <a:rPr b="1" sz="1600"/>
-              <a:t>Målet på nivå 1: du styr bilen manuellt från ROS2 (teleop) — hela kedjan ROS2 → MQTT → ESP fungerar</a:t>
+              <a:t>Målet på nivå 1: styr bilen manuellt från ROS2 (teleop) och berör ALLA rutor i arenan med pennan</a:t>
             </a:r>
           </a:p>
           <a:p>
@@ -9583,7 +9583,7 @@
             </a:pPr>
             <a:r>
               <a:rPr sz="1600" b="0"/>
-              <a:t>ROS2/labs/labb-7 och labb-8 — vägg-undvikaren och "Smart städare" i turtlesim</a:t>
+              <a:t>ROS2/labs/labb-7 och labb-8 — vägg-undvikaren och robotmoppen i turtlesim</a:t>
             </a:r>
           </a:p>
           <a:p>
@@ -10786,7 +10786,7 @@
             </a:pPr>
             <a:r>
               <a:rPr sz="1800" b="1"/>
-              <a:t>Uppdrag: bilen ska på egen hand täcka en 2 × 2 m yta — pennan under bilen ska ha ritat överallt.</a:t>
+              <a:t>Uppdrag: täck en 2 × 2 m yta — pennan under bilen ska ha ritat i alla rutor.</a:t>
             </a:r>
           </a:p>
           <a:p>
@@ -10796,6 +10796,17 @@
               </a:spcAft>
             </a:pPr>
             <a:r>
+              <a:rPr sz="1800" b="1"/>
+              <a:t>Nivå 1: du styr bilen manuellt från ROS2 och berör alla rutor · Nivå 2–3: bilen gör det själv</a:t>
+            </a:r>
+          </a:p>
+          <a:p>
+            <a:pPr>
+              <a:spcAft>
+                <a:spcPts val="400"/>
+              </a:spcAft>
+            </a:pPr>
+            <a:r>
               <a:rPr sz="1800" b="0"/>
               <a:t>Målet är att återskapa din turtlesim-simulering i verkligheten:</a:t>
             </a:r>
@@ -10819,7 +10830,7 @@
             </a:pPr>
             <a:r>
               <a:rPr sz="1600" b="0"/>
-              <a:t>Labb 8 förslag C — "Smart städare" → bilen täcker så stor yta som möjligt</a:t>
+              <a:t>Labb 8 — robotmoppen i simulering → städprogram + täckningsmätning i turtlesim</a:t>
             </a:r>
           </a:p>
           <a:p>
@@ -13405,7 +13416,7 @@
                             <a:srgbClr val="3D3D3D"/>
                           </a:solidFill>
                         </a:rPr>
-                        <a:t>Städarens 60 s i labb 8 C</a:t>
+                        <a:t>Täckningsmätaren i labb 8</a:t>
                       </a:r>
                     </a:p>
                   </a:txBody>
@@ -14487,7 +14498,7 @@
                   <a:srgbClr val="FFFFFF"/>
                 </a:solidFill>
               </a:rPr>
-              <a:t>i turtlesim först —</a:t>
+              <a:t>i turtlesim (labb 8) —</a:t>
             </a:r>
           </a:p>
           <a:p>
@@ -14924,7 +14935,7 @@
                   <a:srgbClr val="3D3D3D"/>
                 </a:solidFill>
               </a:rPr>
-              <a:t>Steg 1–3 är Teknik, steg 4–8 är Programmering. Steg 1–5 räcker för nivå 1 (manuell styrning från ROS2). Grupper om 2: en bygger medan en kodar, byt sedan.</a:t>
+              <a:t>Steg 1–3 är Teknik, steg 4–8 är Programmering. Steg 1–5 + manuell städning av hela arenan = nivå 1. Grupper om 2: en bygger medan en kodar, byt sedan.</a:t>
             </a:r>
           </a:p>
         </p:txBody>

</xml_diff>